<commit_message>
chore: update slide screenshots [main] 09f8a8a197d1f047f0835d05c578640e355e21f7
</commit_message>
<xml_diff>
--- a/screenshots/test-output.pptx
+++ b/screenshots/test-output.pptx
@@ -84,9 +84,10 @@
     <p:sldId id="332" r:id="rId78"/>
     <p:sldId id="333" r:id="rId79"/>
     <p:sldId id="334" r:id="rId80"/>
+    <p:sldId id="335" r:id="rId81"/>
   </p:sldIdLst>
   <p:notesMasterIdLst>
-    <p:notesMasterId r:id="rId81"/>
+    <p:notesMasterId r:id="rId82"/>
   </p:notesMasterIdLst>
   <p:sldSz cx="12192000" cy="6858000"/>
   <p:notesSz cx="6858000" cy="12192000"/>
@@ -7406,6 +7407,94 @@
             <a:fld id="{F7021451-1387-4CA6-816F-3879F97B5CBC}" type="slidenum">
               <a:rPr lang="en-US"/>
               <a:t>8</a:t>
+            </a:fld>
+            <a:endParaRPr lang="en-US"/>
+          </a:p>
+        </p:txBody>
+      </p:sp>
+    </p:spTree>
+    <p:extLst>
+      <p:ext uri="{BB962C8B-B14F-4D97-AF65-F5344CB8AC3E}">
+        <p14:creationId xmlns:p14="http://schemas.microsoft.com/office/powerpoint/2010/main" val="1024086991"/>
+      </p:ext>
+    </p:extLst>
+  </p:cSld>
+  <p:clrMapOvr>
+    <a:masterClrMapping/>
+  </p:clrMapOvr>
+</p:notes>
+</file>
+
+<file path=ppt/notesSlides/notesSlide80.xml><?xml version="1.0" encoding="utf-8"?>
+<p:notes xmlns:a="http://schemas.openxmlformats.org/drawingml/2006/main" xmlns:r="http://schemas.openxmlformats.org/officeDocument/2006/relationships" xmlns:p="http://schemas.openxmlformats.org/presentationml/2006/main">
+  <p:cSld>
+    <p:spTree>
+      <p:nvGrpSpPr>
+        <p:cNvPr id="1" name=""/>
+        <p:cNvGrpSpPr/>
+        <p:nvPr/>
+      </p:nvGrpSpPr>
+      <p:grpSpPr>
+        <a:xfrm>
+          <a:off x="0" y="0"/>
+          <a:ext cx="0" cy="0"/>
+          <a:chOff x="0" y="0"/>
+          <a:chExt cx="0" cy="0"/>
+        </a:xfrm>
+      </p:grpSpPr>
+      <p:sp>
+        <p:nvSpPr>
+          <p:cNvPr id="2" name="Slide Image Placeholder 1"/>
+          <p:cNvSpPr>
+            <a:spLocks noGrp="1" noRot="1" noChangeAspect="1"/>
+          </p:cNvSpPr>
+          <p:nvPr>
+            <p:ph type="sldImg"/>
+          </p:nvPr>
+        </p:nvSpPr>
+        <p:spPr/>
+      </p:sp>
+      <p:sp>
+        <p:nvSpPr>
+          <p:cNvPr id="3" name="Notes Placeholder 2"/>
+          <p:cNvSpPr>
+            <a:spLocks noGrp="1"/>
+          </p:cNvSpPr>
+          <p:nvPr>
+            <p:ph type="body" idx="1"/>
+          </p:nvPr>
+        </p:nvSpPr>
+        <p:spPr/>
+        <p:txBody>
+          <a:bodyPr/>
+          <a:lstStyle/>
+          <a:p>
+            <a:r>
+              <a:rPr lang="en-US" dirty="0"/>
+              <a:t>Expected: yellow marker highlight appears on bold runs inside list items</a:t>
+            </a:r>
+            <a:endParaRPr lang="en-US" dirty="0"/>
+          </a:p>
+        </p:txBody>
+      </p:sp>
+      <p:sp>
+        <p:nvSpPr>
+          <p:cNvPr id="4" name="Slide Number Placeholder 3"/>
+          <p:cNvSpPr>
+            <a:spLocks noGrp="1"/>
+          </p:cNvSpPr>
+          <p:nvPr>
+            <p:ph type="sldNum" sz="quarter" idx="10"/>
+          </p:nvPr>
+        </p:nvSpPr>
+        <p:spPr/>
+        <p:txBody>
+          <a:bodyPr/>
+          <a:lstStyle/>
+          <a:p>
+            <a:fld id="{F7021451-1387-4CA6-816F-3879F97B5CBC}" type="slidenum">
+              <a:rPr lang="en-US"/>
+              <a:t>80</a:t>
             </a:fld>
             <a:endParaRPr lang="en-US"/>
           </a:p>
@@ -49804,6 +49893,309 @@
             <a:fld id="{F7021451-1387-4CA6-816F-3879F97B5CBC}" type="slidenum">
               <a:rPr b="0" lang="en-US"/>
               <a:t>8</a:t>
+            </a:fld>
+            <a:endParaRPr lang="en-US"/>
+          </a:p>
+        </p:txBody>
+      </p:sp>
+    </p:spTree>
+  </p:cSld>
+  <p:clrMapOvr>
+    <a:masterClrMapping/>
+  </p:clrMapOvr>
+</p:sld>
+</file>
+
+<file path=ppt/slides/slide80.xml><?xml version="1.0" encoding="utf-8"?>
+<p:sld xmlns:a="http://schemas.openxmlformats.org/drawingml/2006/main" xmlns:r="http://schemas.openxmlformats.org/officeDocument/2006/relationships" xmlns:p="http://schemas.openxmlformats.org/presentationml/2006/main">
+  <p:cSld name="Slide 80">
+    <p:bg>
+      <p:bgPr>
+        <a:solidFill>
+          <a:srgbClr val="FFFFFF"/>
+        </a:solidFill>
+      </p:bgPr>
+    </p:bg>
+    <p:spTree>
+      <p:nvGrpSpPr>
+        <p:cNvPr id="1" name=""/>
+        <p:cNvGrpSpPr/>
+        <p:nvPr/>
+      </p:nvGrpSpPr>
+      <p:grpSpPr>
+        <a:xfrm>
+          <a:off x="0" y="0"/>
+          <a:ext cx="0" cy="0"/>
+          <a:chOff x="0" y="0"/>
+          <a:chExt cx="0" cy="0"/>
+        </a:xfrm>
+      </p:grpSpPr>
+      <p:sp>
+        <p:nvSpPr>
+          <p:cNvPr id="2" name="Text 0"/>
+          <p:cNvSpPr/>
+          <p:nvPr/>
+        </p:nvSpPr>
+        <p:spPr>
+          <a:xfrm>
+            <a:off x="747713" y="2043559"/>
+            <a:ext cx="11291888" cy="1237357"/>
+          </a:xfrm>
+          <a:prstGeom prst="rect">
+            <a:avLst/>
+          </a:prstGeom>
+          <a:noFill/>
+          <a:ln/>
+        </p:spPr>
+        <p:txBody>
+          <a:bodyPr wrap="square" lIns="0" tIns="0" rIns="0" bIns="132588" rtlCol="0" anchor="t"/>
+          <a:lstStyle/>
+          <a:p>
+            <a:pPr algn="l" indent="0" marL="0">
+              <a:lnSpc>
+                <a:spcPct val="125000"/>
+              </a:lnSpc>
+              <a:buNone/>
+            </a:pPr>
+            <a:r>
+              <a:rPr lang="en-US" sz="3480" b="1" dirty="0">
+                <a:solidFill>
+                  <a:srgbClr val="224466"/>
+                </a:solidFill>
+                <a:latin typeface="Segoe UI" pitchFamily="34" charset="0"/>
+                <a:ea typeface="Segoe UI" pitchFamily="34" charset="-122"/>
+                <a:cs typeface="Segoe UI" pitchFamily="34" charset="-120"/>
+              </a:rPr>
+              <a:t>Slide 80: linear-gradient marker highlight on strong inside list item</a:t>
+            </a:r>
+            <a:endParaRPr lang="en-US" sz="3480" dirty="0"/>
+          </a:p>
+        </p:txBody>
+      </p:sp>
+      <p:sp>
+        <p:nvSpPr>
+          <p:cNvPr id="3" name="Text 1"/>
+          <p:cNvSpPr/>
+          <p:nvPr/>
+        </p:nvSpPr>
+        <p:spPr>
+          <a:xfrm>
+            <a:off x="747713" y="3433316"/>
+            <a:ext cx="10696575" cy="1381125"/>
+          </a:xfrm>
+          <a:prstGeom prst="rect">
+            <a:avLst/>
+          </a:prstGeom>
+          <a:noFill/>
+          <a:ln/>
+        </p:spPr>
+        <p:txBody>
+          <a:bodyPr wrap="square" lIns="0" tIns="0" rIns="0" bIns="0" rtlCol="0" anchor="t"/>
+          <a:lstStyle/>
+          <a:p>
+            <a:pPr algn="l" marL="342900" indent="-342900">
+              <a:lnSpc>
+                <a:spcPct val="150000"/>
+              </a:lnSpc>
+              <a:buSzPct val="100000"/>
+              <a:buChar char="•"/>
+            </a:pPr>
+            <a:r>
+              <a:rPr lang="en-US" sz="2175" dirty="0">
+                <a:solidFill>
+                  <a:srgbClr val="1F2328"/>
+                </a:solidFill>
+                <a:latin typeface="Segoe UI" pitchFamily="34" charset="0"/>
+                <a:ea typeface="Segoe UI" pitchFamily="34" charset="-122"/>
+                <a:cs typeface="Segoe UI" pitchFamily="34" charset="-120"/>
+              </a:rPr>
+              <a:t>Alpha beta gamma </a:t>
+            </a:r>
+            <a:pPr algn="l" marL="342900" indent="-342900">
+              <a:lnSpc>
+                <a:spcPct val="150000"/>
+              </a:lnSpc>
+              <a:buSzPct val="100000"/>
+              <a:buChar char="•"/>
+            </a:pPr>
+            <a:r>
+              <a:rPr lang="en-US" sz="2175" b="1" dirty="0">
+                <a:solidFill>
+                  <a:srgbClr val="1F2328"/>
+                </a:solidFill>
+                <a:highlight>
+                  <a:srgbClr val="FFF2A8"/>
+                </a:highlight>
+                <a:latin typeface="Segoe UI" pitchFamily="34" charset="0"/>
+                <a:ea typeface="Segoe UI" pitchFamily="34" charset="-122"/>
+                <a:cs typeface="Segoe UI" pitchFamily="34" charset="-120"/>
+              </a:rPr>
+              <a:t>Item-1</a:t>
+            </a:r>
+            <a:pPr algn="l" marL="342900" indent="-342900">
+              <a:lnSpc>
+                <a:spcPct val="150000"/>
+              </a:lnSpc>
+              <a:buSzPct val="100000"/>
+              <a:buChar char="•"/>
+            </a:pPr>
+            <a:r>
+              <a:rPr lang="en-US" sz="2175" dirty="0">
+                <a:solidFill>
+                  <a:srgbClr val="1F2328"/>
+                </a:solidFill>
+                <a:latin typeface="Segoe UI" pitchFamily="34" charset="0"/>
+                <a:ea typeface="Segoe UI" pitchFamily="34" charset="-122"/>
+                <a:cs typeface="Segoe UI" pitchFamily="34" charset="-120"/>
+              </a:rPr>
+              <a:t> delta epsilon</a:t>
+            </a:r>
+            <a:endParaRPr lang="en-US" sz="2175" dirty="0"/>
+          </a:p>
+          <a:p>
+            <a:pPr algn="l" marL="342900" indent="-342900">
+              <a:lnSpc>
+                <a:spcPct val="150000"/>
+              </a:lnSpc>
+              <a:buSzPct val="100000"/>
+              <a:buChar char="•"/>
+            </a:pPr>
+            <a:r>
+              <a:rPr lang="en-US" sz="2175" b="1" dirty="0">
+                <a:solidFill>
+                  <a:srgbClr val="1F2328"/>
+                </a:solidFill>
+                <a:highlight>
+                  <a:srgbClr val="FFF2A8"/>
+                </a:highlight>
+                <a:latin typeface="Segoe UI" pitchFamily="34" charset="0"/>
+                <a:ea typeface="Segoe UI" pitchFamily="34" charset="-122"/>
+                <a:cs typeface="Segoe UI" pitchFamily="34" charset="-120"/>
+              </a:rPr>
+              <a:t>Item-2</a:t>
+            </a:r>
+            <a:pPr algn="l" marL="342900" indent="-342900">
+              <a:lnSpc>
+                <a:spcPct val="150000"/>
+              </a:lnSpc>
+              <a:buSzPct val="100000"/>
+              <a:buChar char="•"/>
+            </a:pPr>
+            <a:r>
+              <a:rPr lang="en-US" sz="2175" dirty="0">
+                <a:solidFill>
+                  <a:srgbClr val="1F2328"/>
+                </a:solidFill>
+                <a:latin typeface="Segoe UI" pitchFamily="34" charset="0"/>
+                <a:ea typeface="Segoe UI" pitchFamily="34" charset="-122"/>
+                <a:cs typeface="Segoe UI" pitchFamily="34" charset="-120"/>
+              </a:rPr>
+              <a:t> zeta nu eta</a:t>
+            </a:r>
+            <a:endParaRPr lang="en-US" sz="2175" dirty="0"/>
+          </a:p>
+          <a:p>
+            <a:pPr algn="l" marL="342900" indent="-342900">
+              <a:lnSpc>
+                <a:spcPct val="150000"/>
+              </a:lnSpc>
+              <a:buSzPct val="100000"/>
+              <a:buChar char="•"/>
+            </a:pPr>
+            <a:r>
+              <a:rPr lang="en-US" sz="2175" dirty="0">
+                <a:solidFill>
+                  <a:srgbClr val="1F2328"/>
+                </a:solidFill>
+                <a:latin typeface="Segoe UI" pitchFamily="34" charset="0"/>
+                <a:ea typeface="Segoe UI" pitchFamily="34" charset="-122"/>
+                <a:cs typeface="Segoe UI" pitchFamily="34" charset="-120"/>
+              </a:rPr>
+              <a:t>Theta iota </a:t>
+            </a:r>
+            <a:pPr algn="l" marL="342900" indent="-342900">
+              <a:lnSpc>
+                <a:spcPct val="150000"/>
+              </a:lnSpc>
+              <a:buSzPct val="100000"/>
+              <a:buChar char="•"/>
+            </a:pPr>
+            <a:r>
+              <a:rPr lang="en-US" sz="2175" b="1" dirty="0">
+                <a:solidFill>
+                  <a:srgbClr val="1F2328"/>
+                </a:solidFill>
+                <a:highlight>
+                  <a:srgbClr val="FFF2A8"/>
+                </a:highlight>
+                <a:latin typeface="Segoe UI" pitchFamily="34" charset="0"/>
+                <a:ea typeface="Segoe UI" pitchFamily="34" charset="-122"/>
+                <a:cs typeface="Segoe UI" pitchFamily="34" charset="-120"/>
+              </a:rPr>
+              <a:t>Item-3</a:t>
+            </a:r>
+            <a:pPr algn="l" marL="342900" indent="-342900">
+              <a:lnSpc>
+                <a:spcPct val="150000"/>
+              </a:lnSpc>
+              <a:buSzPct val="100000"/>
+              <a:buChar char="•"/>
+            </a:pPr>
+            <a:r>
+              <a:rPr lang="en-US" sz="2175" dirty="0">
+                <a:solidFill>
+                  <a:srgbClr val="1F2328"/>
+                </a:solidFill>
+                <a:latin typeface="Segoe UI" pitchFamily="34" charset="0"/>
+                <a:ea typeface="Segoe UI" pitchFamily="34" charset="-122"/>
+                <a:cs typeface="Segoe UI" pitchFamily="34" charset="-120"/>
+              </a:rPr>
+              <a:t> kappa lambda</a:t>
+            </a:r>
+            <a:endParaRPr lang="en-US" sz="2175" dirty="0"/>
+          </a:p>
+        </p:txBody>
+      </p:sp>
+      <p:sp>
+        <p:nvSpPr>
+          <p:cNvPr id="25" name="Slide Number Placeholder 0"/>
+          <p:cNvSpPr>
+            <a:spLocks noGrp="1"/>
+          </p:cNvSpPr>
+          <p:nvPr>
+            <p:ph type="sldNum" sz="quarter" idx="4294967295"/>
+          </p:nvPr>
+        </p:nvSpPr>
+        <p:spPr>
+          <a:xfrm>
+            <a:off x="0" y="6343650"/>
+            <a:ext cx="11811000" cy="228600"/>
+          </a:xfrm>
+          <a:prstGeom prst="rect">
+            <a:avLst/>
+          </a:prstGeom>
+          <a:extLst>
+            <a:ext uri="{C572A759-6A51-4108-AA02-DFA0A04FC94B}">
+              <ma14:wrappingTextBoxFlag xmlns:ma14="http://schemas.microsoft.com/office/mac/drawingml/2011/main" val="0"/>
+            </a:ext>
+          </a:extLst>
+        </p:spPr>
+        <p:txBody>
+          <a:bodyPr lIns="0" tIns="0" rIns="0" bIns="0"/>
+          <a:lstStyle>
+            <a:lvl1pPr>
+              <a:defRPr sz="1350">
+                <a:solidFill>
+                  <a:srgbClr val="777777"/>
+                </a:solidFill>
+              </a:defRPr>
+            </a:lvl1pPr>
+          </a:lstStyle>
+          <a:p>
+            <a:pPr algn="r"/>
+            <a:fld id="{F7021451-1387-4CA6-816F-3879F97B5CBC}" type="slidenum">
+              <a:rPr b="0" lang="en-US"/>
+              <a:t>80</a:t>
             </a:fld>
             <a:endParaRPr lang="en-US"/>
           </a:p>

</xml_diff>